<commit_message>
The independent set's six questions are on the board (ruling 21, amended); Units 3 and 4 rebuilt on kit 1230e4c
Co-Authored-By: Claude Opus 5.5 <noreply@anthropic.com>
Claude-Session: https://claude.ai/code/session_015xYWeLUsuszQH6z7ADE9tj
</commit_message>
<xml_diff>
--- a/a7/build/out/u3/A7 3.01 Product Laws of Exponents - Slides.pptx
+++ b/a7/build/out/u3/A7 3.01 Product Laws of Exponents - Slides.pptx
@@ -13582,23 +13582,23 @@
         </p:nvSpPr>
         <p:spPr>
           <a:xfrm>
-            <a:off x="960120" y="2011680"/>
-            <a:ext cx="548640" cy="356616"/>
-          </a:xfrm>
-          <a:prstGeom prst="rect">
-            <a:avLst/>
-          </a:prstGeom>
-          <a:noFill/>
-        </p:spPr>
-        <p:txBody>
-          <a:bodyPr wrap="square" lIns="45720" rIns="45720" tIns="18288" bIns="18288" anchor="t">
+            <a:off x="960120" y="1495043"/>
+            <a:ext cx="548640" cy="457200"/>
+          </a:xfrm>
+          <a:prstGeom prst="rect">
+            <a:avLst/>
+          </a:prstGeom>
+          <a:noFill/>
+        </p:spPr>
+        <p:txBody>
+          <a:bodyPr wrap="square" lIns="45720" rIns="45720" tIns="18288" bIns="18288" anchor="ctr">
             <a:spAutoFit/>
           </a:bodyPr>
           <a:lstStyle/>
           <a:p>
             <a:pPr algn="l"/>
             <a:r>
-              <a:rPr sz="2100" b="1" i="0">
+              <a:rPr sz="2300" b="1" i="0">
                 <a:solidFill>
                   <a:srgbClr val="0B5394"/>
                 </a:solidFill>
@@ -13617,58 +13617,82 @@
         </p:nvSpPr>
         <p:spPr>
           <a:xfrm>
-            <a:off x="1554480" y="2011680"/>
-            <a:ext cx="9829800" cy="411480"/>
-          </a:xfrm>
-          <a:prstGeom prst="rect">
-            <a:avLst/>
-          </a:prstGeom>
-          <a:noFill/>
-        </p:spPr>
-        <p:txBody>
-          <a:bodyPr wrap="square" lIns="45720" rIns="45720" tIns="18288" bIns="18288" anchor="t">
-            <a:spAutoFit/>
+            <a:off x="1554480" y="1495044"/>
+            <a:ext cx="3168165" cy="457200"/>
+          </a:xfrm>
+          <a:prstGeom prst="rect">
+            <a:avLst/>
+          </a:prstGeom>
+          <a:noFill/>
+        </p:spPr>
+        <p:txBody>
+          <a:bodyPr wrap="none" lIns="45720" rIns="45720" tIns="18288" bIns="18288" anchor="ctr">
+            <a:noAutofit/>
           </a:bodyPr>
           <a:lstStyle/>
           <a:p>
             <a:pPr algn="l"/>
             <a:r>
-              <a:rPr sz="2100" b="0" i="0">
+              <a:rPr sz="2300" b="0" i="0">
                 <a:solidFill>
                   <a:srgbClr val="1A1A1A"/>
                 </a:solidFill>
                 <a:latin typeface="Century Schoolbook"/>
               </a:rPr>
-              <a:t>Six questions. Work down the page.</a:t>
-            </a:r>
-          </a:p>
-        </p:txBody>
-      </p:sp>
-      <p:sp>
-        <p:nvSpPr>
-          <p:cNvPr id="10" name="TextBox 9"/>
-          <p:cNvSpPr txBox="1"/>
-          <p:nvPr/>
-        </p:nvSpPr>
-        <p:spPr>
-          <a:xfrm>
-            <a:off x="960120" y="2551176"/>
-            <a:ext cx="548640" cy="356616"/>
-          </a:xfrm>
-          <a:prstGeom prst="rect">
-            <a:avLst/>
-          </a:prstGeom>
-          <a:noFill/>
-        </p:spPr>
-        <p:txBody>
-          <a:bodyPr wrap="square" lIns="45720" rIns="45720" tIns="18288" bIns="18288" anchor="t">
+              <a:t>Write as one power.  </a:t>
+            </a:r>
+          </a:p>
+        </p:txBody>
+      </p:sp>
+      <p:pic>
+        <p:nvPicPr>
+          <p:cNvPr id="10" name="Picture 9" descr="6d3773d9800b92db.png"/>
+          <p:cNvPicPr>
+            <a:picLocks noChangeAspect="1"/>
+          </p:cNvPicPr>
+          <p:nvPr/>
+        </p:nvPicPr>
+        <p:blipFill>
+          <a:blip r:embed="rId2"/>
+          <a:stretch>
+            <a:fillRect/>
+          </a:stretch>
+        </p:blipFill>
+        <p:spPr>
+          <a:xfrm>
+            <a:off x="4585485" y="1583436"/>
+            <a:ext cx="749808" cy="280416"/>
+          </a:xfrm>
+          <a:prstGeom prst="rect">
+            <a:avLst/>
+          </a:prstGeom>
+        </p:spPr>
+      </p:pic>
+      <p:sp>
+        <p:nvSpPr>
+          <p:cNvPr id="11" name="TextBox 10"/>
+          <p:cNvSpPr txBox="1"/>
+          <p:nvPr/>
+        </p:nvSpPr>
+        <p:spPr>
+          <a:xfrm>
+            <a:off x="960120" y="2089403"/>
+            <a:ext cx="548640" cy="457200"/>
+          </a:xfrm>
+          <a:prstGeom prst="rect">
+            <a:avLst/>
+          </a:prstGeom>
+          <a:noFill/>
+        </p:spPr>
+        <p:txBody>
+          <a:bodyPr wrap="square" lIns="45720" rIns="45720" tIns="18288" bIns="18288" anchor="ctr">
             <a:spAutoFit/>
           </a:bodyPr>
           <a:lstStyle/>
           <a:p>
             <a:pPr algn="l"/>
             <a:r>
-              <a:rPr sz="2100" b="1" i="0">
+              <a:rPr sz="2300" b="1" i="0">
                 <a:solidFill>
                   <a:srgbClr val="0B5394"/>
                 </a:solidFill>
@@ -13681,64 +13705,88 @@
       </p:sp>
       <p:sp>
         <p:nvSpPr>
-          <p:cNvPr id="11" name="TextBox 10"/>
-          <p:cNvSpPr txBox="1"/>
-          <p:nvPr/>
-        </p:nvSpPr>
-        <p:spPr>
-          <a:xfrm>
-            <a:off x="1554480" y="2551176"/>
-            <a:ext cx="9829800" cy="411480"/>
-          </a:xfrm>
-          <a:prstGeom prst="rect">
-            <a:avLst/>
-          </a:prstGeom>
-          <a:noFill/>
-        </p:spPr>
-        <p:txBody>
-          <a:bodyPr wrap="square" lIns="45720" rIns="45720" tIns="18288" bIns="18288" anchor="t">
-            <a:spAutoFit/>
+          <p:cNvPr id="12" name="TextBox 11"/>
+          <p:cNvSpPr txBox="1"/>
+          <p:nvPr/>
+        </p:nvSpPr>
+        <p:spPr>
+          <a:xfrm>
+            <a:off x="1554480" y="2089403"/>
+            <a:ext cx="2548440" cy="457200"/>
+          </a:xfrm>
+          <a:prstGeom prst="rect">
+            <a:avLst/>
+          </a:prstGeom>
+          <a:noFill/>
+        </p:spPr>
+        <p:txBody>
+          <a:bodyPr wrap="none" lIns="45720" rIns="45720" tIns="18288" bIns="18288" anchor="ctr">
+            <a:noAutofit/>
           </a:bodyPr>
           <a:lstStyle/>
           <a:p>
             <a:pPr algn="l"/>
             <a:r>
-              <a:rPr sz="2100" b="0" i="0">
+              <a:rPr sz="2300" b="0" i="0">
                 <a:solidFill>
                   <a:srgbClr val="1A1A1A"/>
                 </a:solidFill>
                 <a:latin typeface="Century Schoolbook"/>
               </a:rPr>
-              <a:t>Show the step that does the work, not just the answer.</a:t>
-            </a:r>
-          </a:p>
-        </p:txBody>
-      </p:sp>
-      <p:sp>
-        <p:nvSpPr>
-          <p:cNvPr id="12" name="TextBox 11"/>
-          <p:cNvSpPr txBox="1"/>
-          <p:nvPr/>
-        </p:nvSpPr>
-        <p:spPr>
-          <a:xfrm>
-            <a:off x="960120" y="3090672"/>
-            <a:ext cx="548640" cy="356616"/>
-          </a:xfrm>
-          <a:prstGeom prst="rect">
-            <a:avLst/>
-          </a:prstGeom>
-          <a:noFill/>
-        </p:spPr>
-        <p:txBody>
-          <a:bodyPr wrap="square" lIns="45720" rIns="45720" tIns="18288" bIns="18288" anchor="t">
+              <a:t>Find the value.  </a:t>
+            </a:r>
+          </a:p>
+        </p:txBody>
+      </p:sp>
+      <p:pic>
+        <p:nvPicPr>
+          <p:cNvPr id="13" name="Picture 12" descr="8b7a2cb55dcba947.png"/>
+          <p:cNvPicPr>
+            <a:picLocks noChangeAspect="1"/>
+          </p:cNvPicPr>
+          <p:nvPr/>
+        </p:nvPicPr>
+        <p:blipFill>
+          <a:blip r:embed="rId3"/>
+          <a:stretch>
+            <a:fillRect/>
+          </a:stretch>
+        </p:blipFill>
+        <p:spPr>
+          <a:xfrm>
+            <a:off x="3965760" y="2180844"/>
+            <a:ext cx="758952" cy="274320"/>
+          </a:xfrm>
+          <a:prstGeom prst="rect">
+            <a:avLst/>
+          </a:prstGeom>
+        </p:spPr>
+      </p:pic>
+      <p:sp>
+        <p:nvSpPr>
+          <p:cNvPr id="14" name="TextBox 13"/>
+          <p:cNvSpPr txBox="1"/>
+          <p:nvPr/>
+        </p:nvSpPr>
+        <p:spPr>
+          <a:xfrm>
+            <a:off x="960120" y="2683763"/>
+            <a:ext cx="548640" cy="457200"/>
+          </a:xfrm>
+          <a:prstGeom prst="rect">
+            <a:avLst/>
+          </a:prstGeom>
+          <a:noFill/>
+        </p:spPr>
+        <p:txBody>
+          <a:bodyPr wrap="square" lIns="45720" rIns="45720" tIns="18288" bIns="18288" anchor="ctr">
             <a:spAutoFit/>
           </a:bodyPr>
           <a:lstStyle/>
           <a:p>
             <a:pPr algn="l"/>
             <a:r>
-              <a:rPr sz="2100" b="1" i="0">
+              <a:rPr sz="2300" b="1" i="0">
                 <a:solidFill>
                   <a:srgbClr val="0B5394"/>
                 </a:solidFill>
@@ -13751,39 +13799,404 @@
       </p:sp>
       <p:sp>
         <p:nvSpPr>
-          <p:cNvPr id="13" name="TextBox 12"/>
-          <p:cNvSpPr txBox="1"/>
-          <p:nvPr/>
-        </p:nvSpPr>
-        <p:spPr>
-          <a:xfrm>
-            <a:off x="1554480" y="3090672"/>
-            <a:ext cx="9829800" cy="411480"/>
-          </a:xfrm>
-          <a:prstGeom prst="rect">
-            <a:avLst/>
-          </a:prstGeom>
-          <a:noFill/>
-        </p:spPr>
-        <p:txBody>
-          <a:bodyPr wrap="square" lIns="45720" rIns="45720" tIns="18288" bIns="18288" anchor="t">
-            <a:spAutoFit/>
+          <p:cNvPr id="15" name="TextBox 14"/>
+          <p:cNvSpPr txBox="1"/>
+          <p:nvPr/>
+        </p:nvSpPr>
+        <p:spPr>
+          <a:xfrm>
+            <a:off x="1554480" y="2683763"/>
+            <a:ext cx="3168165" cy="457200"/>
+          </a:xfrm>
+          <a:prstGeom prst="rect">
+            <a:avLst/>
+          </a:prstGeom>
+          <a:noFill/>
+        </p:spPr>
+        <p:txBody>
+          <a:bodyPr wrap="none" lIns="45720" rIns="45720" tIns="18288" bIns="18288" anchor="ctr">
+            <a:noAutofit/>
           </a:bodyPr>
           <a:lstStyle/>
           <a:p>
             <a:pPr algn="l"/>
             <a:r>
-              <a:rPr sz="2100" b="0" i="0">
+              <a:rPr sz="2300" b="0" i="0">
                 <a:solidFill>
                   <a:srgbClr val="1A1A1A"/>
                 </a:solidFill>
                 <a:latin typeface="Century Schoolbook"/>
               </a:rPr>
-              <a:t>Silence until the six minutes are up.</a:t>
-            </a:r>
-          </a:p>
-        </p:txBody>
-      </p:sp>
+              <a:t>Write as one power.  </a:t>
+            </a:r>
+          </a:p>
+        </p:txBody>
+      </p:sp>
+      <p:pic>
+        <p:nvPicPr>
+          <p:cNvPr id="16" name="Picture 15" descr="8e2e3ba64c00d8d6.png"/>
+          <p:cNvPicPr>
+            <a:picLocks noChangeAspect="1"/>
+          </p:cNvPicPr>
+          <p:nvPr/>
+        </p:nvPicPr>
+        <p:blipFill>
+          <a:blip r:embed="rId4"/>
+          <a:stretch>
+            <a:fillRect/>
+          </a:stretch>
+        </p:blipFill>
+        <p:spPr>
+          <a:xfrm>
+            <a:off x="4585485" y="2744723"/>
+            <a:ext cx="618744" cy="335280"/>
+          </a:xfrm>
+          <a:prstGeom prst="rect">
+            <a:avLst/>
+          </a:prstGeom>
+        </p:spPr>
+      </p:pic>
+      <p:sp>
+        <p:nvSpPr>
+          <p:cNvPr id="17" name="TextBox 16"/>
+          <p:cNvSpPr txBox="1"/>
+          <p:nvPr/>
+        </p:nvSpPr>
+        <p:spPr>
+          <a:xfrm>
+            <a:off x="960120" y="3278123"/>
+            <a:ext cx="548640" cy="457200"/>
+          </a:xfrm>
+          <a:prstGeom prst="rect">
+            <a:avLst/>
+          </a:prstGeom>
+          <a:noFill/>
+        </p:spPr>
+        <p:txBody>
+          <a:bodyPr wrap="square" lIns="45720" rIns="45720" tIns="18288" bIns="18288" anchor="ctr">
+            <a:spAutoFit/>
+          </a:bodyPr>
+          <a:lstStyle/>
+          <a:p>
+            <a:pPr algn="l"/>
+            <a:r>
+              <a:rPr sz="2300" b="1" i="0">
+                <a:solidFill>
+                  <a:srgbClr val="0B5394"/>
+                </a:solidFill>
+                <a:latin typeface="Century Schoolbook"/>
+              </a:rPr>
+              <a:t>4.</a:t>
+            </a:r>
+          </a:p>
+        </p:txBody>
+      </p:sp>
+      <p:sp>
+        <p:nvSpPr>
+          <p:cNvPr id="18" name="TextBox 17"/>
+          <p:cNvSpPr txBox="1"/>
+          <p:nvPr/>
+        </p:nvSpPr>
+        <p:spPr>
+          <a:xfrm>
+            <a:off x="1554480" y="3278123"/>
+            <a:ext cx="2548440" cy="457200"/>
+          </a:xfrm>
+          <a:prstGeom prst="rect">
+            <a:avLst/>
+          </a:prstGeom>
+          <a:noFill/>
+        </p:spPr>
+        <p:txBody>
+          <a:bodyPr wrap="none" lIns="45720" rIns="45720" tIns="18288" bIns="18288" anchor="ctr">
+            <a:noAutofit/>
+          </a:bodyPr>
+          <a:lstStyle/>
+          <a:p>
+            <a:pPr algn="l"/>
+            <a:r>
+              <a:rPr sz="2300" b="0" i="0">
+                <a:solidFill>
+                  <a:srgbClr val="1A1A1A"/>
+                </a:solidFill>
+                <a:latin typeface="Century Schoolbook"/>
+              </a:rPr>
+              <a:t>Find the value.  </a:t>
+            </a:r>
+          </a:p>
+        </p:txBody>
+      </p:sp>
+      <p:pic>
+        <p:nvPicPr>
+          <p:cNvPr id="19" name="Picture 18" descr="46f85d9f4b191651.png"/>
+          <p:cNvPicPr>
+            <a:picLocks noChangeAspect="1"/>
+          </p:cNvPicPr>
+          <p:nvPr/>
+        </p:nvPicPr>
+        <p:blipFill>
+          <a:blip r:embed="rId5"/>
+          <a:stretch>
+            <a:fillRect/>
+          </a:stretch>
+        </p:blipFill>
+        <p:spPr>
+          <a:xfrm>
+            <a:off x="3965760" y="3339083"/>
+            <a:ext cx="838200" cy="335280"/>
+          </a:xfrm>
+          <a:prstGeom prst="rect">
+            <a:avLst/>
+          </a:prstGeom>
+        </p:spPr>
+      </p:pic>
+      <p:sp>
+        <p:nvSpPr>
+          <p:cNvPr id="20" name="TextBox 19"/>
+          <p:cNvSpPr txBox="1"/>
+          <p:nvPr/>
+        </p:nvSpPr>
+        <p:spPr>
+          <a:xfrm>
+            <a:off x="960120" y="3872483"/>
+            <a:ext cx="548640" cy="457200"/>
+          </a:xfrm>
+          <a:prstGeom prst="rect">
+            <a:avLst/>
+          </a:prstGeom>
+          <a:noFill/>
+        </p:spPr>
+        <p:txBody>
+          <a:bodyPr wrap="square" lIns="45720" rIns="45720" tIns="18288" bIns="18288" anchor="ctr">
+            <a:spAutoFit/>
+          </a:bodyPr>
+          <a:lstStyle/>
+          <a:p>
+            <a:pPr algn="l"/>
+            <a:r>
+              <a:rPr sz="2300" b="1" i="0">
+                <a:solidFill>
+                  <a:srgbClr val="0B5394"/>
+                </a:solidFill>
+                <a:latin typeface="Century Schoolbook"/>
+              </a:rPr>
+              <a:t>5.</a:t>
+            </a:r>
+          </a:p>
+        </p:txBody>
+      </p:sp>
+      <p:sp>
+        <p:nvSpPr>
+          <p:cNvPr id="21" name="TextBox 20"/>
+          <p:cNvSpPr txBox="1"/>
+          <p:nvPr/>
+        </p:nvSpPr>
+        <p:spPr>
+          <a:xfrm>
+            <a:off x="1554480" y="3872483"/>
+            <a:ext cx="2548440" cy="457200"/>
+          </a:xfrm>
+          <a:prstGeom prst="rect">
+            <a:avLst/>
+          </a:prstGeom>
+          <a:noFill/>
+        </p:spPr>
+        <p:txBody>
+          <a:bodyPr wrap="none" lIns="45720" rIns="45720" tIns="18288" bIns="18288" anchor="ctr">
+            <a:noAutofit/>
+          </a:bodyPr>
+          <a:lstStyle/>
+          <a:p>
+            <a:pPr algn="l"/>
+            <a:r>
+              <a:rPr sz="2300" b="0" i="0">
+                <a:solidFill>
+                  <a:srgbClr val="1A1A1A"/>
+                </a:solidFill>
+                <a:latin typeface="Century Schoolbook"/>
+              </a:rPr>
+              <a:t>Find the value.  </a:t>
+            </a:r>
+          </a:p>
+        </p:txBody>
+      </p:sp>
+      <p:pic>
+        <p:nvPicPr>
+          <p:cNvPr id="22" name="Picture 21" descr="df0ae84d8a3187e4.png"/>
+          <p:cNvPicPr>
+            <a:picLocks noChangeAspect="1"/>
+          </p:cNvPicPr>
+          <p:nvPr/>
+        </p:nvPicPr>
+        <p:blipFill>
+          <a:blip r:embed="rId6"/>
+          <a:stretch>
+            <a:fillRect/>
+          </a:stretch>
+        </p:blipFill>
+        <p:spPr>
+          <a:xfrm>
+            <a:off x="3965760" y="3933444"/>
+            <a:ext cx="1645920" cy="335280"/>
+          </a:xfrm>
+          <a:prstGeom prst="rect">
+            <a:avLst/>
+          </a:prstGeom>
+        </p:spPr>
+      </p:pic>
+      <p:sp>
+        <p:nvSpPr>
+          <p:cNvPr id="23" name="TextBox 22"/>
+          <p:cNvSpPr txBox="1"/>
+          <p:nvPr/>
+        </p:nvSpPr>
+        <p:spPr>
+          <a:xfrm>
+            <a:off x="960120" y="4466844"/>
+            <a:ext cx="548640" cy="457200"/>
+          </a:xfrm>
+          <a:prstGeom prst="rect">
+            <a:avLst/>
+          </a:prstGeom>
+          <a:noFill/>
+        </p:spPr>
+        <p:txBody>
+          <a:bodyPr wrap="square" lIns="45720" rIns="45720" tIns="18288" bIns="18288" anchor="ctr">
+            <a:spAutoFit/>
+          </a:bodyPr>
+          <a:lstStyle/>
+          <a:p>
+            <a:pPr algn="l"/>
+            <a:r>
+              <a:rPr sz="2300" b="1" i="0">
+                <a:solidFill>
+                  <a:srgbClr val="0B5394"/>
+                </a:solidFill>
+                <a:latin typeface="Century Schoolbook"/>
+              </a:rPr>
+              <a:t>6.</a:t>
+            </a:r>
+          </a:p>
+        </p:txBody>
+      </p:sp>
+      <p:sp>
+        <p:nvSpPr>
+          <p:cNvPr id="24" name="TextBox 23"/>
+          <p:cNvSpPr txBox="1"/>
+          <p:nvPr/>
+        </p:nvSpPr>
+        <p:spPr>
+          <a:xfrm>
+            <a:off x="1554480" y="4466844"/>
+            <a:ext cx="2720291" cy="457200"/>
+          </a:xfrm>
+          <a:prstGeom prst="rect">
+            <a:avLst/>
+          </a:prstGeom>
+          <a:noFill/>
+        </p:spPr>
+        <p:txBody>
+          <a:bodyPr wrap="none" lIns="45720" rIns="45720" tIns="18288" bIns="18288" anchor="ctr">
+            <a:noAutofit/>
+          </a:bodyPr>
+          <a:lstStyle/>
+          <a:p>
+            <a:pPr algn="l"/>
+            <a:r>
+              <a:rPr sz="2300" b="0" i="0">
+                <a:solidFill>
+                  <a:srgbClr val="1A1A1A"/>
+                </a:solidFill>
+                <a:latin typeface="Century Schoolbook"/>
+              </a:rPr>
+              <a:t>Find the value of </a:t>
+            </a:r>
+          </a:p>
+        </p:txBody>
+      </p:sp>
+      <p:pic>
+        <p:nvPicPr>
+          <p:cNvPr id="25" name="Picture 24" descr="0afe177f69dd5e06.png"/>
+          <p:cNvPicPr>
+            <a:picLocks noChangeAspect="1"/>
+          </p:cNvPicPr>
+          <p:nvPr/>
+        </p:nvPicPr>
+        <p:blipFill>
+          <a:blip r:embed="rId7"/>
+          <a:stretch>
+            <a:fillRect/>
+          </a:stretch>
+        </p:blipFill>
+        <p:spPr>
+          <a:xfrm>
+            <a:off x="4137611" y="4620768"/>
+            <a:ext cx="155448" cy="149352"/>
+          </a:xfrm>
+          <a:prstGeom prst="rect">
+            <a:avLst/>
+          </a:prstGeom>
+        </p:spPr>
+      </p:pic>
+      <p:sp>
+        <p:nvSpPr>
+          <p:cNvPr id="26" name="TextBox 25"/>
+          <p:cNvSpPr txBox="1"/>
+          <p:nvPr/>
+        </p:nvSpPr>
+        <p:spPr>
+          <a:xfrm>
+            <a:off x="4293059" y="4466844"/>
+            <a:ext cx="468561" cy="457200"/>
+          </a:xfrm>
+          <a:prstGeom prst="rect">
+            <a:avLst/>
+          </a:prstGeom>
+          <a:noFill/>
+        </p:spPr>
+        <p:txBody>
+          <a:bodyPr wrap="none" lIns="45720" rIns="45720" tIns="18288" bIns="18288" anchor="ctr">
+            <a:noAutofit/>
+          </a:bodyPr>
+          <a:lstStyle/>
+          <a:p>
+            <a:pPr algn="l"/>
+            <a:r>
+              <a:rPr sz="2300" b="0" i="0">
+                <a:solidFill>
+                  <a:srgbClr val="1A1A1A"/>
+                </a:solidFill>
+                <a:latin typeface="Century Schoolbook"/>
+              </a:rPr>
+              <a:t>.  </a:t>
+            </a:r>
+          </a:p>
+        </p:txBody>
+      </p:sp>
+      <p:pic>
+        <p:nvPicPr>
+          <p:cNvPr id="27" name="Picture 26" descr="46cee507e28ffbc7.png"/>
+          <p:cNvPicPr>
+            <a:picLocks noChangeAspect="1"/>
+          </p:cNvPicPr>
+          <p:nvPr/>
+        </p:nvPicPr>
+        <p:blipFill>
+          <a:blip r:embed="rId8"/>
+          <a:stretch>
+            <a:fillRect/>
+          </a:stretch>
+        </p:blipFill>
+        <p:spPr>
+          <a:xfrm>
+            <a:off x="4624460" y="4555236"/>
+            <a:ext cx="1374648" cy="280416"/>
+          </a:xfrm>
+          <a:prstGeom prst="rect">
+            <a:avLst/>
+          </a:prstGeom>
+        </p:spPr>
+      </p:pic>
     </p:spTree>
   </p:cSld>
   <p:clrMapOvr>

</xml_diff>

<commit_message>
Ruling 43: a practice problem never repeats what the lesson already showed — Units 3 and 4 rewritten, rebuilt and installed at 0 findings (kit 050fc2b)
Co-Authored-By: Claude Opus 5.5 <noreply@anthropic.com>
Claude-Session: https://claude.ai/code/session_015xYWeLUsuszQH6z7ADE9tj
</commit_message>
<xml_diff>
--- a/a7/build/out/u3/A7 3.01 Product Laws of Exponents - Slides.pptx
+++ b/a7/build/out/u3/A7 3.01 Product Laws of Exponents - Slides.pptx
@@ -7833,7 +7833,7 @@
       </p:sp>
       <p:pic>
         <p:nvPicPr>
-          <p:cNvPr id="8" name="Picture 7" descr="5affe015bded252a.png"/>
+          <p:cNvPr id="8" name="Picture 7" descr="613e669cfd3b6d49.png"/>
           <p:cNvPicPr>
             <a:picLocks noChangeAspect="1"/>
           </p:cNvPicPr>
@@ -7847,8 +7847,8 @@
         </p:blipFill>
         <p:spPr>
           <a:xfrm>
-            <a:off x="5410199" y="2194560"/>
-            <a:ext cx="1341120" cy="505968"/>
+            <a:off x="5285231" y="2194560"/>
+            <a:ext cx="1591056" cy="505968"/>
           </a:xfrm>
           <a:prstGeom prst="rect">
             <a:avLst/>
@@ -8120,7 +8120,7 @@
       </p:sp>
       <p:pic>
         <p:nvPicPr>
-          <p:cNvPr id="8" name="Picture 7" descr="b79ccee972120db7.png"/>
+          <p:cNvPr id="8" name="Picture 7" descr="7c404630188da250.png"/>
           <p:cNvPicPr>
             <a:picLocks noChangeAspect="1"/>
           </p:cNvPicPr>
@@ -8134,8 +8134,8 @@
         </p:blipFill>
         <p:spPr>
           <a:xfrm>
-            <a:off x="5410199" y="2103120"/>
-            <a:ext cx="1341120" cy="509016"/>
+            <a:off x="5283707" y="2103120"/>
+            <a:ext cx="1594104" cy="509016"/>
           </a:xfrm>
           <a:prstGeom prst="rect">
             <a:avLst/>
@@ -8144,7 +8144,7 @@
       </p:pic>
       <p:pic>
         <p:nvPicPr>
-          <p:cNvPr id="9" name="Picture 8" descr="40c6ca452737ffb3.png"/>
+          <p:cNvPr id="9" name="Picture 8" descr="c7daae656677eced.png"/>
           <p:cNvPicPr>
             <a:picLocks noChangeAspect="1"/>
           </p:cNvPicPr>
@@ -8158,8 +8158,8 @@
         </p:blipFill>
         <p:spPr>
           <a:xfrm>
-            <a:off x="3770375" y="2935224"/>
-            <a:ext cx="4730496" cy="368808"/>
+            <a:off x="3226308" y="2935224"/>
+            <a:ext cx="5818632" cy="368808"/>
           </a:xfrm>
           <a:prstGeom prst="rect">
             <a:avLst/>
@@ -8196,7 +8196,7 @@
                 </a:solidFill>
                 <a:latin typeface="Lexend"/>
               </a:rPr>
-              <a:t>Answer:   1000</a:t>
+              <a:t>Answer:   27,000</a:t>
             </a:r>
           </a:p>
         </p:txBody>
@@ -12768,7 +12768,7 @@
         </p:nvSpPr>
         <p:spPr>
           <a:xfrm>
-            <a:off x="2913590" y="2746579"/>
+            <a:off x="3024842" y="2746579"/>
             <a:ext cx="2222015" cy="457200"/>
           </a:xfrm>
           <a:prstGeom prst="rect">
@@ -12797,7 +12797,7 @@
       </p:sp>
       <p:pic>
         <p:nvPicPr>
-          <p:cNvPr id="10" name="Picture 9" descr="3c467de68f6a9099.png"/>
+          <p:cNvPr id="10" name="Picture 9" descr="2ac5303067d16b6b.png"/>
           <p:cNvPicPr>
             <a:picLocks noChangeAspect="1"/>
           </p:cNvPicPr>
@@ -12811,8 +12811,8 @@
         </p:blipFill>
         <p:spPr>
           <a:xfrm>
-            <a:off x="4998446" y="2770963"/>
-            <a:ext cx="1920240" cy="408432"/>
+            <a:off x="5109698" y="2770963"/>
+            <a:ext cx="1697736" cy="408432"/>
           </a:xfrm>
           <a:prstGeom prst="rect">
             <a:avLst/>
@@ -12827,7 +12827,7 @@
         </p:nvSpPr>
         <p:spPr>
           <a:xfrm>
-            <a:off x="6918686" y="2746579"/>
+            <a:off x="6807434" y="2746579"/>
             <a:ext cx="2466403" cy="457200"/>
           </a:xfrm>
           <a:prstGeom prst="rect">
@@ -13160,7 +13160,7 @@
         </p:nvSpPr>
         <p:spPr>
           <a:xfrm>
-            <a:off x="2912066" y="2655139"/>
+            <a:off x="3023318" y="2655139"/>
             <a:ext cx="2222015" cy="457200"/>
           </a:xfrm>
           <a:prstGeom prst="rect">
@@ -13189,7 +13189,7 @@
       </p:sp>
       <p:pic>
         <p:nvPicPr>
-          <p:cNvPr id="10" name="Picture 9" descr="8bb89340cbe98788.png"/>
+          <p:cNvPr id="10" name="Picture 9" descr="d92052160a3b4a7a.png"/>
           <p:cNvPicPr>
             <a:picLocks noChangeAspect="1"/>
           </p:cNvPicPr>
@@ -13203,8 +13203,8 @@
         </p:blipFill>
         <p:spPr>
           <a:xfrm>
-            <a:off x="4996922" y="2679523"/>
-            <a:ext cx="1923288" cy="408432"/>
+            <a:off x="5108174" y="2679523"/>
+            <a:ext cx="1700784" cy="408432"/>
           </a:xfrm>
           <a:prstGeom prst="rect">
             <a:avLst/>
@@ -13219,7 +13219,7 @@
         </p:nvSpPr>
         <p:spPr>
           <a:xfrm>
-            <a:off x="6920210" y="2655139"/>
+            <a:off x="6808958" y="2655139"/>
             <a:ext cx="2466403" cy="457200"/>
           </a:xfrm>
           <a:prstGeom prst="rect">
@@ -13283,7 +13283,7 @@
       </p:sp>
       <p:pic>
         <p:nvPicPr>
-          <p:cNvPr id="13" name="Picture 12" descr="df452ab7ad4dafcb.png"/>
+          <p:cNvPr id="13" name="Picture 12" descr="5256d7b7f99b417b.png"/>
           <p:cNvPicPr>
             <a:picLocks noChangeAspect="1"/>
           </p:cNvPicPr>
@@ -13298,7 +13298,7 @@
         <p:spPr>
           <a:xfrm>
             <a:off x="2541610" y="4013023"/>
-            <a:ext cx="1569720" cy="265176"/>
+            <a:ext cx="1417320" cy="265176"/>
           </a:xfrm>
           <a:prstGeom prst="rect">
             <a:avLst/>
@@ -13307,7 +13307,7 @@
       </p:pic>
       <p:pic>
         <p:nvPicPr>
-          <p:cNvPr id="14" name="Picture 13" descr="5b67aed5b26673ef.png"/>
+          <p:cNvPr id="14" name="Picture 13" descr="5fe753b3272aace9.png"/>
           <p:cNvPicPr>
             <a:picLocks noChangeAspect="1"/>
           </p:cNvPicPr>
@@ -13321,8 +13321,8 @@
         </p:blipFill>
         <p:spPr>
           <a:xfrm>
-            <a:off x="2541610" y="4520515"/>
-            <a:ext cx="1024128" cy="256032"/>
+            <a:off x="2541610" y="4522039"/>
+            <a:ext cx="1018032" cy="252984"/>
           </a:xfrm>
           <a:prstGeom prst="rect">
             <a:avLst/>
@@ -13359,7 +13359,7 @@
                 </a:solidFill>
                 <a:latin typeface="Lexend"/>
               </a:rPr>
-              <a:t>Answer:   No — (10 + (−2))</a:t>
+              <a:t>Answer:   No — (9 + (−3))</a:t>
             </a:r>
             <a:r>
               <a:rPr sz="3040" b="1" i="0" baseline="30000">
@@ -13377,7 +13377,7 @@
                 </a:solidFill>
                 <a:latin typeface="Lexend"/>
               </a:rPr>
-              <a:t> = 8</a:t>
+              <a:t> = 6</a:t>
             </a:r>
             <a:r>
               <a:rPr sz="3040" b="1" i="0" baseline="30000">
@@ -13395,7 +13395,7 @@
                 </a:solidFill>
                 <a:latin typeface="Lexend"/>
               </a:rPr>
-              <a:t> = 512</a:t>
+              <a:t> = 216</a:t>
             </a:r>
           </a:p>
         </p:txBody>

</xml_diff>

<commit_message>
Ruling 43, second pass: 3.01 board 6, 3.T1 board 2, 3.T2 board 2 and independent 5, 4.02 board 9 get numbers of their own; Units 3 and 4 rebuilt at 0 findings
Co-Authored-By: Claude Opus 5.5 <noreply@anthropic.com>
Claude-Session: https://claude.ai/code/session_015xYWeLUsuszQH6z7ADE9tj
</commit_message>
<xml_diff>
--- a/a7/build/out/u3/A7 3.01 Product Laws of Exponents - Slides.pptx
+++ b/a7/build/out/u3/A7 3.01 Product Laws of Exponents - Slides.pptx
@@ -9942,7 +9942,7 @@
       </p:sp>
       <p:pic>
         <p:nvPicPr>
-          <p:cNvPr id="8" name="Picture 7" descr="086b323a5a1e494d.png"/>
+          <p:cNvPr id="8" name="Picture 7" descr="f79d3fb964505a9d.png"/>
           <p:cNvPicPr>
             <a:picLocks noChangeAspect="1"/>
           </p:cNvPicPr>
@@ -9956,8 +9956,8 @@
         </p:blipFill>
         <p:spPr>
           <a:xfrm>
-            <a:off x="5611367" y="2194560"/>
-            <a:ext cx="938784" cy="505968"/>
+            <a:off x="5599176" y="2194560"/>
+            <a:ext cx="963167" cy="502920"/>
           </a:xfrm>
           <a:prstGeom prst="rect">
             <a:avLst/>
@@ -9972,7 +9972,7 @@
         </p:nvSpPr>
         <p:spPr>
           <a:xfrm>
-            <a:off x="777240" y="2929128"/>
+            <a:off x="777240" y="2926080"/>
             <a:ext cx="10607040" cy="465151"/>
           </a:xfrm>
           <a:prstGeom prst="rect">
@@ -10007,7 +10007,7 @@
         </p:nvSpPr>
         <p:spPr>
           <a:xfrm>
-            <a:off x="1874519" y="3595447"/>
+            <a:off x="1874519" y="3592399"/>
             <a:ext cx="4572000" cy="548640"/>
           </a:xfrm>
           <a:prstGeom prst="rect">
@@ -10047,7 +10047,7 @@
                 </a:solidFill>
                 <a:latin typeface="Lexend"/>
               </a:rPr>
-              <a:t>5</a:t>
+              <a:t>7</a:t>
             </a:r>
           </a:p>
         </p:txBody>
@@ -10060,7 +10060,7 @@
         </p:nvSpPr>
         <p:spPr>
           <a:xfrm>
-            <a:off x="6629400" y="3595447"/>
+            <a:off x="6629400" y="3592399"/>
             <a:ext cx="4572000" cy="548640"/>
           </a:xfrm>
           <a:prstGeom prst="rect">
@@ -10091,7 +10091,7 @@
                 </a:solidFill>
                 <a:latin typeface="Lexend"/>
               </a:rPr>
-              <a:t>4</a:t>
+              <a:t>8</a:t>
             </a:r>
             <a:r>
               <a:rPr sz="2280" b="0" i="0" baseline="30000">
@@ -10100,7 +10100,7 @@
                 </a:solidFill>
                 <a:latin typeface="Lexend"/>
               </a:rPr>
-              <a:t>6</a:t>
+              <a:t>12</a:t>
             </a:r>
           </a:p>
         </p:txBody>
@@ -10113,7 +10113,7 @@
         </p:nvSpPr>
         <p:spPr>
           <a:xfrm>
-            <a:off x="1874519" y="4281247"/>
+            <a:off x="1874519" y="4278199"/>
             <a:ext cx="4572000" cy="548640"/>
           </a:xfrm>
           <a:prstGeom prst="rect">
@@ -10153,7 +10153,7 @@
                 </a:solidFill>
                 <a:latin typeface="Lexend"/>
               </a:rPr>
-              <a:t>6</a:t>
+              <a:t>12</a:t>
             </a:r>
           </a:p>
         </p:txBody>
@@ -10166,7 +10166,7 @@
         </p:nvSpPr>
         <p:spPr>
           <a:xfrm>
-            <a:off x="6629400" y="4281247"/>
+            <a:off x="6629400" y="4278199"/>
             <a:ext cx="4572000" cy="548640"/>
           </a:xfrm>
           <a:prstGeom prst="rect">
@@ -10206,7 +10206,7 @@
                 </a:solidFill>
                 <a:latin typeface="Lexend"/>
               </a:rPr>
-              <a:t>9</a:t>
+              <a:t>64</a:t>
             </a:r>
           </a:p>
         </p:txBody>
@@ -10219,7 +10219,7 @@
         </p:nvSpPr>
         <p:spPr>
           <a:xfrm>
-            <a:off x="777240" y="5287087"/>
+            <a:off x="777240" y="5284039"/>
             <a:ext cx="10607040" cy="457200"/>
           </a:xfrm>
           <a:prstGeom prst="rect">
@@ -10476,7 +10476,7 @@
       </p:sp>
       <p:pic>
         <p:nvPicPr>
-          <p:cNvPr id="8" name="Picture 7" descr="9a96c530649f2cb7.png"/>
+          <p:cNvPr id="8" name="Picture 7" descr="9039f0d29f00b5c3.png"/>
           <p:cNvPicPr>
             <a:picLocks noChangeAspect="1"/>
           </p:cNvPicPr>
@@ -10490,8 +10490,8 @@
         </p:blipFill>
         <p:spPr>
           <a:xfrm>
-            <a:off x="5609844" y="2103120"/>
-            <a:ext cx="941832" cy="505968"/>
+            <a:off x="5600699" y="2103120"/>
+            <a:ext cx="960120" cy="505968"/>
           </a:xfrm>
           <a:prstGeom prst="rect">
             <a:avLst/>
@@ -10535,7 +10535,7 @@
       </p:sp>
       <p:pic>
         <p:nvPicPr>
-          <p:cNvPr id="10" name="Picture 9" descr="5669e1447e03fc57.png"/>
+          <p:cNvPr id="10" name="Picture 9" descr="fbd677bc81794072.png"/>
           <p:cNvPicPr>
             <a:picLocks noChangeAspect="1"/>
           </p:cNvPicPr>
@@ -10549,8 +10549,8 @@
         </p:blipFill>
         <p:spPr>
           <a:xfrm>
-            <a:off x="4977383" y="3505531"/>
-            <a:ext cx="2316480" cy="371856"/>
+            <a:off x="4898135" y="3505531"/>
+            <a:ext cx="2471928" cy="371856"/>
           </a:xfrm>
           <a:prstGeom prst="rect">
             <a:avLst/>
@@ -10596,7 +10596,7 @@
                 </a:solidFill>
                 <a:latin typeface="Lexend"/>
               </a:rPr>
-              <a:t>6</a:t>
+              <a:t>12</a:t>
             </a:r>
           </a:p>
         </p:txBody>

</xml_diff>